<commit_message>
Week 3 decks finished: rebuild Wed (Planning Day) + Thu (Demo Night), add tool + screenshot-slot slides to Mon/Tue
- Wed 'Planning Day: What's the problem?' (10 slides): keep-your-value, find-the-need
  (interview/persona), the value tree bottoming out in build prompts, storyboard, tools
  (storyboard + AI pitch), a screenshot slot, the team activity, and the carry-to-Thursday.
- Thu 'Demo Night: What's the solution?' (10 slides): build, the pitch video, five presentation
  beats, the NEW grading (four Canvas checkpoints -> 25% project + 15% presentation), logistics.
- Mon + Tue: added a consolidated TOOLS slide and a screenshot-placeholder slide each.
- Sora corrected everywhere -> Veo 3.1 / Runway / Kling / Pika (OpenAI retired the Sora app Apr 2026).
- Registry titles updated for Wed/Thu.

Co-Authored-By: Claude Fable 5 <noreply@anthropic.com>
</commit_message>
<xml_diff>
--- a/slides/Week3-Mon-User-Testing-I.pptx
+++ b/slides/Week3-Mon-User-Testing-I.pptx
@@ -20,6 +20,8 @@
     <p:sldId id="268" r:id="rId20"/>
     <p:sldId id="269" r:id="rId21"/>
     <p:sldId id="270" r:id="rId22"/>
+    <p:sldId id="271" r:id="rId23"/>
+    <p:sldId id="272" r:id="rId24"/>
   </p:sldIdLst>
   <p:sldSz cx="12191695" cy="6858000" type="screen4x3"/>
   <p:notesSz cx="6858000" cy="9144000"/>
@@ -6775,6 +6777,653 @@
       <p:sp>
         <p:nvSpPr>
           <p:cNvPr id="11" name="TextBox 10"/>
+          <p:cNvSpPr txBox="1"/>
+          <p:nvPr/>
+        </p:nvSpPr>
+        <p:spPr>
+          <a:xfrm>
+            <a:off x="640080" y="6355080"/>
+            <a:ext cx="10972800" cy="365760"/>
+          </a:xfrm>
+          <a:prstGeom prst="rect">
+            <a:avLst/>
+          </a:prstGeom>
+          <a:noFill/>
+        </p:spPr>
+        <p:txBody>
+          <a:bodyPr wrap="square" anchor="t">
+            <a:spAutoFit/>
+          </a:bodyPr>
+          <a:lstStyle/>
+          <a:p>
+            <a:pPr algn="l">
+              <a:lnSpc>
+                <a:spcPct val="100000"/>
+              </a:lnSpc>
+            </a:pPr>
+            <a:r>
+              <a:rPr sz="1000" b="0">
+                <a:solidFill>
+                  <a:srgbClr val="5A6474"/>
+                </a:solidFill>
+                <a:latin typeface="Courier New"/>
+              </a:rPr>
+              <a:t>Good Code, Good Vibes · TECHIE 1121 · Cornell Tech · Summer 2026</a:t>
+            </a:r>
+          </a:p>
+        </p:txBody>
+      </p:sp>
+    </p:spTree>
+  </p:cSld>
+  <p:clrMapOvr>
+    <a:masterClrMapping/>
+  </p:clrMapOvr>
+</p:sld>
+</file>
+
+<file path=ppt/slides/slide16.xml><?xml version="1.0" encoding="utf-8"?>
+<p:sld xmlns:a="http://schemas.openxmlformats.org/drawingml/2006/main" xmlns:p="http://schemas.openxmlformats.org/presentationml/2006/main" xmlns:r="http://schemas.openxmlformats.org/officeDocument/2006/relationships">
+  <p:cSld>
+    <p:bg>
+      <p:bgPr>
+        <a:solidFill>
+          <a:srgbClr val="0B0E14"/>
+        </a:solidFill>
+        <a:effectLst/>
+      </p:bgPr>
+    </p:bg>
+    <p:spTree>
+      <p:nvGrpSpPr>
+        <p:cNvPr id="1" name=""/>
+        <p:cNvGrpSpPr/>
+        <p:nvPr/>
+      </p:nvGrpSpPr>
+      <p:grpSpPr/>
+      <p:sp>
+        <p:nvSpPr>
+          <p:cNvPr id="2" name="TextBox 1"/>
+          <p:cNvSpPr txBox="1"/>
+          <p:nvPr/>
+        </p:nvSpPr>
+        <p:spPr>
+          <a:xfrm>
+            <a:off x="640080" y="502920"/>
+            <a:ext cx="10058400" cy="365760"/>
+          </a:xfrm>
+          <a:prstGeom prst="rect">
+            <a:avLst/>
+          </a:prstGeom>
+          <a:noFill/>
+        </p:spPr>
+        <p:txBody>
+          <a:bodyPr wrap="square" anchor="t">
+            <a:spAutoFit/>
+          </a:bodyPr>
+          <a:lstStyle/>
+          <a:p>
+            <a:pPr algn="l">
+              <a:lnSpc>
+                <a:spcPct val="100000"/>
+              </a:lnSpc>
+            </a:pPr>
+            <a:r>
+              <a:rPr sz="1300" b="1">
+                <a:solidFill>
+                  <a:srgbClr val="00FF41"/>
+                </a:solidFill>
+                <a:latin typeface="Courier New"/>
+              </a:rPr>
+              <a:t>TOOLS FOR TODAY</a:t>
+            </a:r>
+          </a:p>
+        </p:txBody>
+      </p:sp>
+      <p:sp>
+        <p:nvSpPr>
+          <p:cNvPr id="3" name="Rectangle 2"/>
+          <p:cNvSpPr/>
+          <p:nvPr/>
+        </p:nvSpPr>
+        <p:spPr>
+          <a:xfrm>
+            <a:off x="640080" y="932688"/>
+            <a:ext cx="822960" cy="73152"/>
+          </a:xfrm>
+          <a:prstGeom prst="rect">
+            <a:avLst/>
+          </a:prstGeom>
+          <a:solidFill>
+            <a:srgbClr val="00FF41"/>
+          </a:solidFill>
+          <a:ln>
+            <a:noFill/>
+          </a:ln>
+          <a:effectLst/>
+        </p:spPr>
+        <p:style>
+          <a:lnRef idx="1">
+            <a:schemeClr val="accent1"/>
+          </a:lnRef>
+          <a:fillRef idx="3">
+            <a:schemeClr val="accent1"/>
+          </a:fillRef>
+          <a:effectRef idx="2">
+            <a:schemeClr val="accent1"/>
+          </a:effectRef>
+          <a:fontRef idx="minor">
+            <a:schemeClr val="lt1"/>
+          </a:fontRef>
+        </p:style>
+        <p:txBody>
+          <a:bodyPr rtlCol="0" anchor="ctr"/>
+          <a:lstStyle/>
+          <a:p>
+            <a:pPr algn="ctr"/>
+          </a:p>
+        </p:txBody>
+      </p:sp>
+      <p:sp>
+        <p:nvSpPr>
+          <p:cNvPr id="4" name="TextBox 3"/>
+          <p:cNvSpPr txBox="1"/>
+          <p:nvPr/>
+        </p:nvSpPr>
+        <p:spPr>
+          <a:xfrm>
+            <a:off x="640080" y="1188720"/>
+            <a:ext cx="10972800" cy="1097280"/>
+          </a:xfrm>
+          <a:prstGeom prst="rect">
+            <a:avLst/>
+          </a:prstGeom>
+          <a:noFill/>
+        </p:spPr>
+        <p:txBody>
+          <a:bodyPr wrap="square" anchor="t">
+            <a:spAutoFit/>
+          </a:bodyPr>
+          <a:lstStyle/>
+          <a:p>
+            <a:pPr algn="l">
+              <a:lnSpc>
+                <a:spcPct val="100000"/>
+              </a:lnSpc>
+            </a:pPr>
+            <a:r>
+              <a:rPr sz="3400" b="1">
+                <a:solidFill>
+                  <a:srgbClr val="F5F7FA"/>
+                </a:solidFill>
+                <a:latin typeface="Arial"/>
+              </a:rPr>
+              <a:t>Record, drive, edit, caption</a:t>
+            </a:r>
+          </a:p>
+        </p:txBody>
+      </p:sp>
+      <p:sp>
+        <p:nvSpPr>
+          <p:cNvPr id="5" name="TextBox 4"/>
+          <p:cNvSpPr txBox="1"/>
+          <p:nvPr/>
+        </p:nvSpPr>
+        <p:spPr>
+          <a:xfrm>
+            <a:off x="658368" y="2286000"/>
+            <a:ext cx="10881360" cy="3657600"/>
+          </a:xfrm>
+          <a:prstGeom prst="rect">
+            <a:avLst/>
+          </a:prstGeom>
+          <a:noFill/>
+        </p:spPr>
+        <p:txBody>
+          <a:bodyPr wrap="square" anchor="t">
+            <a:spAutoFit/>
+          </a:bodyPr>
+          <a:lstStyle/>
+          <a:p>
+            <a:pPr algn="l">
+              <a:lnSpc>
+                <a:spcPct val="112000"/>
+              </a:lnSpc>
+            </a:pPr>
+            <a:r>
+              <a:rPr sz="2000" b="1">
+                <a:solidFill>
+                  <a:srgbClr val="00FF41"/>
+                </a:solidFill>
+                <a:latin typeface="Arial"/>
+              </a:rPr>
+              <a:t>•  </a:t>
+            </a:r>
+            <a:r>
+              <a:rPr sz="2000" b="0">
+                <a:solidFill>
+                  <a:srgbClr val="F5F7FA"/>
+                </a:solidFill>
+                <a:latin typeface="Arial"/>
+              </a:rPr>
+              <a:t>Record: QuickTime (Mac) / Xbox Game Bar (Win) / Loom / OBS - screen + mic together.</a:t>
+            </a:r>
+          </a:p>
+          <a:p>
+            <a:pPr algn="l">
+              <a:lnSpc>
+                <a:spcPct val="112000"/>
+              </a:lnSpc>
+            </a:pPr>
+            <a:r>
+              <a:rPr sz="2000" b="1">
+                <a:solidFill>
+                  <a:srgbClr val="00FF41"/>
+                </a:solidFill>
+                <a:latin typeface="Arial"/>
+              </a:rPr>
+              <a:t>•  </a:t>
+            </a:r>
+            <a:r>
+              <a:rPr sz="2000" b="0">
+                <a:solidFill>
+                  <a:srgbClr val="F5F7FA"/>
+                </a:solidFill>
+                <a:latin typeface="Arial"/>
+              </a:rPr>
+              <a:t>Agent testing: Antigravity, Chrome DevTools MCP, Playwright MCP, or browser-use - an AI drives your live URL.</a:t>
+            </a:r>
+          </a:p>
+          <a:p>
+            <a:pPr algn="l">
+              <a:lnSpc>
+                <a:spcPct val="112000"/>
+              </a:lnSpc>
+            </a:pPr>
+            <a:r>
+              <a:rPr sz="2000" b="1">
+                <a:solidFill>
+                  <a:srgbClr val="00FF41"/>
+                </a:solidFill>
+                <a:latin typeface="Arial"/>
+              </a:rPr>
+              <a:t>•  </a:t>
+            </a:r>
+            <a:r>
+              <a:rPr sz="2000" b="0">
+                <a:solidFill>
+                  <a:srgbClr val="F5F7FA"/>
+                </a:solidFill>
+                <a:latin typeface="Arial"/>
+              </a:rPr>
+              <a:t>Edit + speed up: CapCut, iMovie, or Clipchamp - cut to &lt;=5 min, speed the slow parts.</a:t>
+            </a:r>
+          </a:p>
+          <a:p>
+            <a:pPr algn="l">
+              <a:lnSpc>
+                <a:spcPct val="112000"/>
+              </a:lnSpc>
+            </a:pPr>
+            <a:r>
+              <a:rPr sz="2000" b="1">
+                <a:solidFill>
+                  <a:srgbClr val="00FF41"/>
+                </a:solidFill>
+                <a:latin typeface="Arial"/>
+              </a:rPr>
+              <a:t>•  </a:t>
+            </a:r>
+            <a:r>
+              <a:rPr sz="2000" b="0">
+                <a:solidFill>
+                  <a:srgbClr val="F5F7FA"/>
+                </a:solidFill>
+                <a:latin typeface="Arial"/>
+              </a:rPr>
+              <a:t>Captions: upload to YouTube (unlisted), turn on auto-captions.</a:t>
+            </a:r>
+          </a:p>
+          <a:p>
+            <a:pPr algn="l">
+              <a:lnSpc>
+                <a:spcPct val="112000"/>
+              </a:lnSpc>
+            </a:pPr>
+            <a:r>
+              <a:rPr sz="2000" b="1">
+                <a:solidFill>
+                  <a:srgbClr val="00FF41"/>
+                </a:solidFill>
+                <a:latin typeface="Arial"/>
+              </a:rPr>
+              <a:t>•  </a:t>
+            </a:r>
+            <a:r>
+              <a:rPr sz="2000" b="0">
+                <a:solidFill>
+                  <a:srgbClr val="F5F7FA"/>
+                </a:solidFill>
+                <a:latin typeface="Arial"/>
+              </a:rPr>
+              <a:t>Real UX tools (optional): Maze or Lyssna for prototype tests, Lookback for moderated sessions.</a:t>
+            </a:r>
+          </a:p>
+        </p:txBody>
+      </p:sp>
+      <p:sp>
+        <p:nvSpPr>
+          <p:cNvPr id="6" name="TextBox 5"/>
+          <p:cNvSpPr txBox="1"/>
+          <p:nvPr/>
+        </p:nvSpPr>
+        <p:spPr>
+          <a:xfrm>
+            <a:off x="640080" y="6355080"/>
+            <a:ext cx="10972800" cy="365760"/>
+          </a:xfrm>
+          <a:prstGeom prst="rect">
+            <a:avLst/>
+          </a:prstGeom>
+          <a:noFill/>
+        </p:spPr>
+        <p:txBody>
+          <a:bodyPr wrap="square" anchor="t">
+            <a:spAutoFit/>
+          </a:bodyPr>
+          <a:lstStyle/>
+          <a:p>
+            <a:pPr algn="l">
+              <a:lnSpc>
+                <a:spcPct val="100000"/>
+              </a:lnSpc>
+            </a:pPr>
+            <a:r>
+              <a:rPr sz="1000" b="0">
+                <a:solidFill>
+                  <a:srgbClr val="5A6474"/>
+                </a:solidFill>
+                <a:latin typeface="Courier New"/>
+              </a:rPr>
+              <a:t>Good Code, Good Vibes · TECHIE 1121 · Cornell Tech · Summer 2026</a:t>
+            </a:r>
+          </a:p>
+        </p:txBody>
+      </p:sp>
+    </p:spTree>
+  </p:cSld>
+  <p:clrMapOvr>
+    <a:masterClrMapping/>
+  </p:clrMapOvr>
+</p:sld>
+</file>
+
+<file path=ppt/slides/slide17.xml><?xml version="1.0" encoding="utf-8"?>
+<p:sld xmlns:a="http://schemas.openxmlformats.org/drawingml/2006/main" xmlns:p="http://schemas.openxmlformats.org/presentationml/2006/main" xmlns:r="http://schemas.openxmlformats.org/officeDocument/2006/relationships">
+  <p:cSld>
+    <p:bg>
+      <p:bgPr>
+        <a:solidFill>
+          <a:srgbClr val="0B0E14"/>
+        </a:solidFill>
+        <a:effectLst/>
+      </p:bgPr>
+    </p:bg>
+    <p:spTree>
+      <p:nvGrpSpPr>
+        <p:cNvPr id="1" name=""/>
+        <p:cNvGrpSpPr/>
+        <p:nvPr/>
+      </p:nvGrpSpPr>
+      <p:grpSpPr/>
+      <p:sp>
+        <p:nvSpPr>
+          <p:cNvPr id="2" name="TextBox 1"/>
+          <p:cNvSpPr txBox="1"/>
+          <p:nvPr/>
+        </p:nvSpPr>
+        <p:spPr>
+          <a:xfrm>
+            <a:off x="640080" y="502920"/>
+            <a:ext cx="10058400" cy="365760"/>
+          </a:xfrm>
+          <a:prstGeom prst="rect">
+            <a:avLst/>
+          </a:prstGeom>
+          <a:noFill/>
+        </p:spPr>
+        <p:txBody>
+          <a:bodyPr wrap="square" anchor="t">
+            <a:spAutoFit/>
+          </a:bodyPr>
+          <a:lstStyle/>
+          <a:p>
+            <a:pPr algn="l">
+              <a:lnSpc>
+                <a:spcPct val="100000"/>
+              </a:lnSpc>
+            </a:pPr>
+            <a:r>
+              <a:rPr sz="1300" b="1">
+                <a:solidFill>
+                  <a:srgbClr val="00FF41"/>
+                </a:solidFill>
+                <a:latin typeface="Courier New"/>
+              </a:rPr>
+              <a:t>SCREENSHOT SLOT</a:t>
+            </a:r>
+          </a:p>
+        </p:txBody>
+      </p:sp>
+      <p:sp>
+        <p:nvSpPr>
+          <p:cNvPr id="3" name="Rectangle 2"/>
+          <p:cNvSpPr/>
+          <p:nvPr/>
+        </p:nvSpPr>
+        <p:spPr>
+          <a:xfrm>
+            <a:off x="640080" y="932688"/>
+            <a:ext cx="822960" cy="73152"/>
+          </a:xfrm>
+          <a:prstGeom prst="rect">
+            <a:avLst/>
+          </a:prstGeom>
+          <a:solidFill>
+            <a:srgbClr val="00FF41"/>
+          </a:solidFill>
+          <a:ln>
+            <a:noFill/>
+          </a:ln>
+          <a:effectLst/>
+        </p:spPr>
+        <p:style>
+          <a:lnRef idx="1">
+            <a:schemeClr val="accent1"/>
+          </a:lnRef>
+          <a:fillRef idx="3">
+            <a:schemeClr val="accent1"/>
+          </a:fillRef>
+          <a:effectRef idx="2">
+            <a:schemeClr val="accent1"/>
+          </a:effectRef>
+          <a:fontRef idx="minor">
+            <a:schemeClr val="lt1"/>
+          </a:fontRef>
+        </p:style>
+        <p:txBody>
+          <a:bodyPr rtlCol="0" anchor="ctr"/>
+          <a:lstStyle/>
+          <a:p>
+            <a:pPr algn="ctr"/>
+          </a:p>
+        </p:txBody>
+      </p:sp>
+      <p:sp>
+        <p:nvSpPr>
+          <p:cNvPr id="4" name="TextBox 3"/>
+          <p:cNvSpPr txBox="1"/>
+          <p:nvPr/>
+        </p:nvSpPr>
+        <p:spPr>
+          <a:xfrm>
+            <a:off x="640080" y="1188720"/>
+            <a:ext cx="10972800" cy="914400"/>
+          </a:xfrm>
+          <a:prstGeom prst="rect">
+            <a:avLst/>
+          </a:prstGeom>
+          <a:noFill/>
+        </p:spPr>
+        <p:txBody>
+          <a:bodyPr wrap="square" anchor="t">
+            <a:spAutoFit/>
+          </a:bodyPr>
+          <a:lstStyle/>
+          <a:p>
+            <a:pPr algn="l">
+              <a:lnSpc>
+                <a:spcPct val="100000"/>
+              </a:lnSpc>
+            </a:pPr>
+            <a:r>
+              <a:rPr sz="3000" b="1">
+                <a:solidFill>
+                  <a:srgbClr val="F5F7FA"/>
+                </a:solidFill>
+                <a:latin typeface="Arial"/>
+              </a:rPr>
+              <a:t>Show a real test in action</a:t>
+            </a:r>
+          </a:p>
+        </p:txBody>
+      </p:sp>
+      <p:sp>
+        <p:nvSpPr>
+          <p:cNvPr id="5" name="Rounded Rectangle 4"/>
+          <p:cNvSpPr/>
+          <p:nvPr/>
+        </p:nvSpPr>
+        <p:spPr>
+          <a:xfrm>
+            <a:off x="2194560" y="2331720"/>
+            <a:ext cx="7772400" cy="3566160"/>
+          </a:xfrm>
+          <a:prstGeom prst="roundRect">
+            <a:avLst/>
+          </a:prstGeom>
+          <a:solidFill>
+            <a:srgbClr val="151B26"/>
+          </a:solidFill>
+          <a:ln w="19050">
+            <a:solidFill>
+              <a:srgbClr val="00FF41"/>
+            </a:solidFill>
+            <a:prstDash val="dash"/>
+          </a:ln>
+          <a:effectLst/>
+        </p:spPr>
+        <p:style>
+          <a:lnRef idx="1">
+            <a:schemeClr val="accent1"/>
+          </a:lnRef>
+          <a:fillRef idx="3">
+            <a:schemeClr val="accent1"/>
+          </a:fillRef>
+          <a:effectRef idx="2">
+            <a:schemeClr val="accent1"/>
+          </a:effectRef>
+          <a:fontRef idx="minor">
+            <a:schemeClr val="lt1"/>
+          </a:fontRef>
+        </p:style>
+        <p:txBody>
+          <a:bodyPr rtlCol="0" anchor="ctr"/>
+          <a:lstStyle/>
+          <a:p>
+            <a:pPr algn="ctr"/>
+          </a:p>
+        </p:txBody>
+      </p:sp>
+      <p:sp>
+        <p:nvSpPr>
+          <p:cNvPr id="6" name="TextBox 5"/>
+          <p:cNvSpPr txBox="1"/>
+          <p:nvPr/>
+        </p:nvSpPr>
+        <p:spPr>
+          <a:xfrm>
+            <a:off x="2194560" y="3383280"/>
+            <a:ext cx="7772400" cy="731520"/>
+          </a:xfrm>
+          <a:prstGeom prst="rect">
+            <a:avLst/>
+          </a:prstGeom>
+          <a:noFill/>
+        </p:spPr>
+        <p:txBody>
+          <a:bodyPr wrap="square" anchor="t">
+            <a:spAutoFit/>
+          </a:bodyPr>
+          <a:lstStyle/>
+          <a:p>
+            <a:pPr algn="ctr">
+              <a:lnSpc>
+                <a:spcPct val="100000"/>
+              </a:lnSpc>
+            </a:pPr>
+            <a:r>
+              <a:rPr sz="2200" b="1">
+                <a:solidFill>
+                  <a:srgbClr val="00FF41"/>
+                </a:solidFill>
+                <a:latin typeface="Courier New"/>
+              </a:rPr>
+              <a:t>[ screenshot / clip still goes here ]</a:t>
+            </a:r>
+          </a:p>
+        </p:txBody>
+      </p:sp>
+      <p:sp>
+        <p:nvSpPr>
+          <p:cNvPr id="7" name="TextBox 6"/>
+          <p:cNvSpPr txBox="1"/>
+          <p:nvPr/>
+        </p:nvSpPr>
+        <p:spPr>
+          <a:xfrm>
+            <a:off x="2194560" y="4114800"/>
+            <a:ext cx="7772400" cy="731520"/>
+          </a:xfrm>
+          <a:prstGeom prst="rect">
+            <a:avLst/>
+          </a:prstGeom>
+          <a:noFill/>
+        </p:spPr>
+        <p:txBody>
+          <a:bodyPr wrap="square" anchor="t">
+            <a:spAutoFit/>
+          </a:bodyPr>
+          <a:lstStyle/>
+          <a:p>
+            <a:pPr algn="ctr">
+              <a:lnSpc>
+                <a:spcPct val="100000"/>
+              </a:lnSpc>
+            </a:pPr>
+            <a:r>
+              <a:rPr sz="1400" b="0">
+                <a:solidFill>
+                  <a:srgbClr val="8A94A6"/>
+                </a:solidFill>
+                <a:latin typeface="Arial"/>
+              </a:rPr>
+              <a:t>e.g. a tester mid-task, or your AI agent driving the live site</a:t>
+            </a:r>
+          </a:p>
+        </p:txBody>
+      </p:sp>
+      <p:sp>
+        <p:nvSpPr>
+          <p:cNvPr id="8" name="TextBox 7"/>
           <p:cNvSpPr txBox="1"/>
           <p:nvPr/>
         </p:nvSpPr>

</xml_diff>